<commit_message>
Model Overview expanded with more details.
</commit_message>
<xml_diff>
--- a/assets/assets.pptx
+++ b/assets/assets.pptx
@@ -5,7 +5,7 @@
     <p:sldMasterId id="2147483648" r:id="rId1"/>
   </p:sldMasterIdLst>
   <p:notesMasterIdLst>
-    <p:notesMasterId r:id="rId10"/>
+    <p:notesMasterId r:id="rId11"/>
   </p:notesMasterIdLst>
   <p:sldIdLst>
     <p:sldId id="257" r:id="rId2"/>
@@ -16,6 +16,7 @@
     <p:sldId id="262" r:id="rId7"/>
     <p:sldId id="263" r:id="rId8"/>
     <p:sldId id="264" r:id="rId9"/>
+    <p:sldId id="266" r:id="rId10"/>
   </p:sldIdLst>
   <p:sldSz cx="12192000" cy="6858000"/>
   <p:notesSz cx="6858000" cy="9144000"/>
@@ -204,7 +205,7 @@
           <a:p>
             <a:fld id="{19AEFDCD-AE0B-1646-8877-3CDD2F5E1237}" type="datetimeFigureOut">
               <a:rPr lang="en-US" smtClean="0"/>
-              <a:t>8/5/26</a:t>
+              <a:t>9/16/26</a:t>
             </a:fld>
             <a:endParaRPr lang="en-US"/>
           </a:p>
@@ -1438,7 +1439,7 @@
           <a:p>
             <a:fld id="{8ADA360F-AEB3-ED4F-A06C-859F2B7CCC29}" type="datetimeFigureOut">
               <a:rPr lang="en-US" smtClean="0"/>
-              <a:t>8/5/26</a:t>
+              <a:t>9/16/26</a:t>
             </a:fld>
             <a:endParaRPr lang="en-US"/>
           </a:p>
@@ -1636,7 +1637,7 @@
           <a:p>
             <a:fld id="{8ADA360F-AEB3-ED4F-A06C-859F2B7CCC29}" type="datetimeFigureOut">
               <a:rPr lang="en-US" smtClean="0"/>
-              <a:t>8/5/26</a:t>
+              <a:t>9/16/26</a:t>
             </a:fld>
             <a:endParaRPr lang="en-US"/>
           </a:p>
@@ -1844,7 +1845,7 @@
           <a:p>
             <a:fld id="{8ADA360F-AEB3-ED4F-A06C-859F2B7CCC29}" type="datetimeFigureOut">
               <a:rPr lang="en-US" smtClean="0"/>
-              <a:t>8/5/26</a:t>
+              <a:t>9/16/26</a:t>
             </a:fld>
             <a:endParaRPr lang="en-US"/>
           </a:p>
@@ -2042,7 +2043,7 @@
           <a:p>
             <a:fld id="{8ADA360F-AEB3-ED4F-A06C-859F2B7CCC29}" type="datetimeFigureOut">
               <a:rPr lang="en-US" smtClean="0"/>
-              <a:t>8/5/26</a:t>
+              <a:t>9/16/26</a:t>
             </a:fld>
             <a:endParaRPr lang="en-US"/>
           </a:p>
@@ -2317,7 +2318,7 @@
           <a:p>
             <a:fld id="{8ADA360F-AEB3-ED4F-A06C-859F2B7CCC29}" type="datetimeFigureOut">
               <a:rPr lang="en-US" smtClean="0"/>
-              <a:t>8/5/26</a:t>
+              <a:t>9/16/26</a:t>
             </a:fld>
             <a:endParaRPr lang="en-US"/>
           </a:p>
@@ -2582,7 +2583,7 @@
           <a:p>
             <a:fld id="{8ADA360F-AEB3-ED4F-A06C-859F2B7CCC29}" type="datetimeFigureOut">
               <a:rPr lang="en-US" smtClean="0"/>
-              <a:t>8/5/26</a:t>
+              <a:t>9/16/26</a:t>
             </a:fld>
             <a:endParaRPr lang="en-US"/>
           </a:p>
@@ -2994,7 +2995,7 @@
           <a:p>
             <a:fld id="{8ADA360F-AEB3-ED4F-A06C-859F2B7CCC29}" type="datetimeFigureOut">
               <a:rPr lang="en-US" smtClean="0"/>
-              <a:t>8/5/26</a:t>
+              <a:t>9/16/26</a:t>
             </a:fld>
             <a:endParaRPr lang="en-US"/>
           </a:p>
@@ -3135,7 +3136,7 @@
           <a:p>
             <a:fld id="{8ADA360F-AEB3-ED4F-A06C-859F2B7CCC29}" type="datetimeFigureOut">
               <a:rPr lang="en-US" smtClean="0"/>
-              <a:t>8/5/26</a:t>
+              <a:t>9/16/26</a:t>
             </a:fld>
             <a:endParaRPr lang="en-US"/>
           </a:p>
@@ -3248,7 +3249,7 @@
           <a:p>
             <a:fld id="{8ADA360F-AEB3-ED4F-A06C-859F2B7CCC29}" type="datetimeFigureOut">
               <a:rPr lang="en-US" smtClean="0"/>
-              <a:t>8/5/26</a:t>
+              <a:t>9/16/26</a:t>
             </a:fld>
             <a:endParaRPr lang="en-US"/>
           </a:p>
@@ -3559,7 +3560,7 @@
           <a:p>
             <a:fld id="{8ADA360F-AEB3-ED4F-A06C-859F2B7CCC29}" type="datetimeFigureOut">
               <a:rPr lang="en-US" smtClean="0"/>
-              <a:t>8/5/26</a:t>
+              <a:t>9/16/26</a:t>
             </a:fld>
             <a:endParaRPr lang="en-US"/>
           </a:p>
@@ -3847,7 +3848,7 @@
           <a:p>
             <a:fld id="{8ADA360F-AEB3-ED4F-A06C-859F2B7CCC29}" type="datetimeFigureOut">
               <a:rPr lang="en-US" smtClean="0"/>
-              <a:t>8/5/26</a:t>
+              <a:t>9/16/26</a:t>
             </a:fld>
             <a:endParaRPr lang="en-US"/>
           </a:p>
@@ -4088,7 +4089,7 @@
           <a:p>
             <a:fld id="{8ADA360F-AEB3-ED4F-A06C-859F2B7CCC29}" type="datetimeFigureOut">
               <a:rPr lang="en-US" smtClean="0"/>
-              <a:t>8/5/26</a:t>
+              <a:t>9/16/26</a:t>
             </a:fld>
             <a:endParaRPr lang="en-US"/>
           </a:p>
@@ -10597,6 +10598,86 @@
     <p:extLst>
       <p:ext uri="{BB962C8B-B14F-4D97-AF65-F5344CB8AC3E}">
         <p14:creationId xmlns:p14="http://schemas.microsoft.com/office/powerpoint/2010/main" val="3069116991"/>
+      </p:ext>
+    </p:extLst>
+  </p:cSld>
+  <p:clrMapOvr>
+    <a:masterClrMapping/>
+  </p:clrMapOvr>
+</p:sld>
+</file>
+
+<file path=ppt/slides/slide9.xml><?xml version="1.0" encoding="utf-8"?>
+<p:sld xmlns:a="http://schemas.openxmlformats.org/drawingml/2006/main" xmlns:r="http://schemas.openxmlformats.org/officeDocument/2006/relationships" xmlns:p="http://schemas.openxmlformats.org/presentationml/2006/main">
+  <p:cSld>
+    <p:spTree>
+      <p:nvGrpSpPr>
+        <p:cNvPr id="1" name=""/>
+        <p:cNvGrpSpPr/>
+        <p:nvPr/>
+      </p:nvGrpSpPr>
+      <p:grpSpPr>
+        <a:xfrm>
+          <a:off x="0" y="0"/>
+          <a:ext cx="0" cy="0"/>
+          <a:chOff x="0" y="0"/>
+          <a:chExt cx="0" cy="0"/>
+        </a:xfrm>
+      </p:grpSpPr>
+      <p:sp>
+        <p:nvSpPr>
+          <p:cNvPr id="2" name="Title 1">
+            <a:extLst>
+              <a:ext uri="{FF2B5EF4-FFF2-40B4-BE49-F238E27FC236}">
+                <a16:creationId xmlns:a16="http://schemas.microsoft.com/office/drawing/2014/main" id="{29BF19C3-8855-670B-F76C-45D8A3BC23CF}"/>
+              </a:ext>
+            </a:extLst>
+          </p:cNvPr>
+          <p:cNvSpPr>
+            <a:spLocks noGrp="1"/>
+          </p:cNvSpPr>
+          <p:nvPr>
+            <p:ph type="title"/>
+          </p:nvPr>
+        </p:nvSpPr>
+        <p:spPr/>
+        <p:txBody>
+          <a:bodyPr/>
+          <a:lstStyle/>
+          <a:p>
+            <a:endParaRPr lang="en-US"/>
+          </a:p>
+        </p:txBody>
+      </p:sp>
+      <p:sp>
+        <p:nvSpPr>
+          <p:cNvPr id="3" name="Content Placeholder 2">
+            <a:extLst>
+              <a:ext uri="{FF2B5EF4-FFF2-40B4-BE49-F238E27FC236}">
+                <a16:creationId xmlns:a16="http://schemas.microsoft.com/office/drawing/2014/main" id="{F81C4773-9DBB-B2B5-219D-EF1F7FE12E38}"/>
+              </a:ext>
+            </a:extLst>
+          </p:cNvPr>
+          <p:cNvSpPr>
+            <a:spLocks noGrp="1"/>
+          </p:cNvSpPr>
+          <p:nvPr>
+            <p:ph idx="1"/>
+          </p:nvPr>
+        </p:nvSpPr>
+        <p:spPr/>
+        <p:txBody>
+          <a:bodyPr/>
+          <a:lstStyle/>
+          <a:p>
+            <a:endParaRPr lang="en-US"/>
+          </a:p>
+        </p:txBody>
+      </p:sp>
+    </p:spTree>
+    <p:extLst>
+      <p:ext uri="{BB962C8B-B14F-4D97-AF65-F5344CB8AC3E}">
+        <p14:creationId xmlns:p14="http://schemas.microsoft.com/office/powerpoint/2010/main" val="3849868303"/>
       </p:ext>
     </p:extLst>
   </p:cSld>

</xml_diff>